<commit_message>
adding quick mocks of new logo
</commit_message>
<xml_diff>
--- a/app/resource/Imagery.pptx
+++ b/app/resource/Imagery.pptx
@@ -6,6 +6,8 @@
   </p:sldMasterIdLst>
   <p:sldIdLst>
     <p:sldId id="256" r:id="rId2"/>
+    <p:sldId id="257" r:id="rId3"/>
+    <p:sldId id="258" r:id="rId4"/>
   </p:sldIdLst>
   <p:sldSz cx="12192000" cy="6858000"/>
   <p:notesSz cx="6858000" cy="9144000"/>
@@ -104,6 +106,11 @@
       </a:defRPr>
     </a:lvl9pPr>
   </p:defaultTextStyle>
+  <p:extLst>
+    <p:ext uri="{EFAFB233-063F-42B5-8137-9DF3F51BA10A}">
+      <p15:sldGuideLst xmlns:p15="http://schemas.microsoft.com/office/powerpoint/2012/main"/>
+    </p:ext>
+  </p:extLst>
 </p:presentation>
 </file>
 
@@ -149,10 +156,9 @@
           </a:lstStyle>
           <a:p>
             <a:r>
-              <a:rPr lang="en-US" smtClean="0"/>
+              <a:rPr lang="en-US"/>
               <a:t>Click to edit Master title style</a:t>
             </a:r>
-            <a:endParaRPr lang="en-US"/>
           </a:p>
         </p:txBody>
       </p:sp>
@@ -214,10 +220,9 @@
           </a:lstStyle>
           <a:p>
             <a:r>
-              <a:rPr lang="en-US" smtClean="0"/>
+              <a:rPr lang="en-US"/>
               <a:t>Click to edit Master subtitle style</a:t>
             </a:r>
-            <a:endParaRPr lang="en-US"/>
           </a:p>
         </p:txBody>
       </p:sp>
@@ -238,7 +243,7 @@
           <a:p>
             <a:fld id="{5CD31FE7-93CC-4E45-AF1D-A5855231BD86}" type="datetimeFigureOut">
               <a:rPr lang="en-US" smtClean="0"/>
-              <a:t>1/13/2016</a:t>
+              <a:t>10/20/2025</a:t>
             </a:fld>
             <a:endParaRPr lang="en-US"/>
           </a:p>
@@ -332,10 +337,9 @@
           <a:lstStyle/>
           <a:p>
             <a:r>
-              <a:rPr lang="en-US" smtClean="0"/>
+              <a:rPr lang="en-US"/>
               <a:t>Click to edit Master title style</a:t>
             </a:r>
-            <a:endParaRPr lang="en-US"/>
           </a:p>
         </p:txBody>
       </p:sp>
@@ -356,38 +360,37 @@
           <a:p>
             <a:pPr lvl="0"/>
             <a:r>
-              <a:rPr lang="en-US" smtClean="0"/>
+              <a:rPr lang="en-US"/>
               <a:t>Click to edit Master text styles</a:t>
             </a:r>
           </a:p>
           <a:p>
             <a:pPr lvl="1"/>
             <a:r>
-              <a:rPr lang="en-US" smtClean="0"/>
+              <a:rPr lang="en-US"/>
               <a:t>Second level</a:t>
             </a:r>
           </a:p>
           <a:p>
             <a:pPr lvl="2"/>
             <a:r>
-              <a:rPr lang="en-US" smtClean="0"/>
+              <a:rPr lang="en-US"/>
               <a:t>Third level</a:t>
             </a:r>
           </a:p>
           <a:p>
             <a:pPr lvl="3"/>
             <a:r>
-              <a:rPr lang="en-US" smtClean="0"/>
+              <a:rPr lang="en-US"/>
               <a:t>Fourth level</a:t>
             </a:r>
           </a:p>
           <a:p>
             <a:pPr lvl="4"/>
             <a:r>
-              <a:rPr lang="en-US" smtClean="0"/>
+              <a:rPr lang="en-US"/>
               <a:t>Fifth level</a:t>
             </a:r>
-            <a:endParaRPr lang="en-US"/>
           </a:p>
         </p:txBody>
       </p:sp>
@@ -408,7 +411,7 @@
           <a:p>
             <a:fld id="{5CD31FE7-93CC-4E45-AF1D-A5855231BD86}" type="datetimeFigureOut">
               <a:rPr lang="en-US" smtClean="0"/>
-              <a:t>1/13/2016</a:t>
+              <a:t>10/20/2025</a:t>
             </a:fld>
             <a:endParaRPr lang="en-US"/>
           </a:p>
@@ -507,10 +510,9 @@
           <a:lstStyle/>
           <a:p>
             <a:r>
-              <a:rPr lang="en-US" smtClean="0"/>
+              <a:rPr lang="en-US"/>
               <a:t>Click to edit Master title style</a:t>
             </a:r>
-            <a:endParaRPr lang="en-US"/>
           </a:p>
         </p:txBody>
       </p:sp>
@@ -536,38 +538,37 @@
           <a:p>
             <a:pPr lvl="0"/>
             <a:r>
-              <a:rPr lang="en-US" smtClean="0"/>
+              <a:rPr lang="en-US"/>
               <a:t>Click to edit Master text styles</a:t>
             </a:r>
           </a:p>
           <a:p>
             <a:pPr lvl="1"/>
             <a:r>
-              <a:rPr lang="en-US" smtClean="0"/>
+              <a:rPr lang="en-US"/>
               <a:t>Second level</a:t>
             </a:r>
           </a:p>
           <a:p>
             <a:pPr lvl="2"/>
             <a:r>
-              <a:rPr lang="en-US" smtClean="0"/>
+              <a:rPr lang="en-US"/>
               <a:t>Third level</a:t>
             </a:r>
           </a:p>
           <a:p>
             <a:pPr lvl="3"/>
             <a:r>
-              <a:rPr lang="en-US" smtClean="0"/>
+              <a:rPr lang="en-US"/>
               <a:t>Fourth level</a:t>
             </a:r>
           </a:p>
           <a:p>
             <a:pPr lvl="4"/>
             <a:r>
-              <a:rPr lang="en-US" smtClean="0"/>
+              <a:rPr lang="en-US"/>
               <a:t>Fifth level</a:t>
             </a:r>
-            <a:endParaRPr lang="en-US"/>
           </a:p>
         </p:txBody>
       </p:sp>
@@ -588,7 +589,7 @@
           <a:p>
             <a:fld id="{5CD31FE7-93CC-4E45-AF1D-A5855231BD86}" type="datetimeFigureOut">
               <a:rPr lang="en-US" smtClean="0"/>
-              <a:t>1/13/2016</a:t>
+              <a:t>10/20/2025</a:t>
             </a:fld>
             <a:endParaRPr lang="en-US"/>
           </a:p>
@@ -682,10 +683,9 @@
           <a:lstStyle/>
           <a:p>
             <a:r>
-              <a:rPr lang="en-US" smtClean="0"/>
+              <a:rPr lang="en-US"/>
               <a:t>Click to edit Master title style</a:t>
             </a:r>
-            <a:endParaRPr lang="en-US"/>
           </a:p>
         </p:txBody>
       </p:sp>
@@ -706,38 +706,37 @@
           <a:p>
             <a:pPr lvl="0"/>
             <a:r>
-              <a:rPr lang="en-US" smtClean="0"/>
+              <a:rPr lang="en-US"/>
               <a:t>Click to edit Master text styles</a:t>
             </a:r>
           </a:p>
           <a:p>
             <a:pPr lvl="1"/>
             <a:r>
-              <a:rPr lang="en-US" smtClean="0"/>
+              <a:rPr lang="en-US"/>
               <a:t>Second level</a:t>
             </a:r>
           </a:p>
           <a:p>
             <a:pPr lvl="2"/>
             <a:r>
-              <a:rPr lang="en-US" smtClean="0"/>
+              <a:rPr lang="en-US"/>
               <a:t>Third level</a:t>
             </a:r>
           </a:p>
           <a:p>
             <a:pPr lvl="3"/>
             <a:r>
-              <a:rPr lang="en-US" smtClean="0"/>
+              <a:rPr lang="en-US"/>
               <a:t>Fourth level</a:t>
             </a:r>
           </a:p>
           <a:p>
             <a:pPr lvl="4"/>
             <a:r>
-              <a:rPr lang="en-US" smtClean="0"/>
+              <a:rPr lang="en-US"/>
               <a:t>Fifth level</a:t>
             </a:r>
-            <a:endParaRPr lang="en-US"/>
           </a:p>
         </p:txBody>
       </p:sp>
@@ -758,7 +757,7 @@
           <a:p>
             <a:fld id="{5CD31FE7-93CC-4E45-AF1D-A5855231BD86}" type="datetimeFigureOut">
               <a:rPr lang="en-US" smtClean="0"/>
-              <a:t>1/13/2016</a:t>
+              <a:t>10/20/2025</a:t>
             </a:fld>
             <a:endParaRPr lang="en-US"/>
           </a:p>
@@ -861,10 +860,9 @@
           </a:lstStyle>
           <a:p>
             <a:r>
-              <a:rPr lang="en-US" smtClean="0"/>
+              <a:rPr lang="en-US"/>
               <a:t>Click to edit Master title style</a:t>
             </a:r>
-            <a:endParaRPr lang="en-US"/>
           </a:p>
         </p:txBody>
       </p:sp>
@@ -981,7 +979,7 @@
           <a:p>
             <a:pPr lvl="0"/>
             <a:r>
-              <a:rPr lang="en-US" smtClean="0"/>
+              <a:rPr lang="en-US"/>
               <a:t>Click to edit Master text styles</a:t>
             </a:r>
           </a:p>
@@ -1004,7 +1002,7 @@
           <a:p>
             <a:fld id="{5CD31FE7-93CC-4E45-AF1D-A5855231BD86}" type="datetimeFigureOut">
               <a:rPr lang="en-US" smtClean="0"/>
-              <a:t>1/13/2016</a:t>
+              <a:t>10/20/2025</a:t>
             </a:fld>
             <a:endParaRPr lang="en-US"/>
           </a:p>
@@ -1098,10 +1096,9 @@
           <a:lstStyle/>
           <a:p>
             <a:r>
-              <a:rPr lang="en-US" smtClean="0"/>
+              <a:rPr lang="en-US"/>
               <a:t>Click to edit Master title style</a:t>
             </a:r>
-            <a:endParaRPr lang="en-US"/>
           </a:p>
         </p:txBody>
       </p:sp>
@@ -1127,38 +1124,37 @@
           <a:p>
             <a:pPr lvl="0"/>
             <a:r>
-              <a:rPr lang="en-US" smtClean="0"/>
+              <a:rPr lang="en-US"/>
               <a:t>Click to edit Master text styles</a:t>
             </a:r>
           </a:p>
           <a:p>
             <a:pPr lvl="1"/>
             <a:r>
-              <a:rPr lang="en-US" smtClean="0"/>
+              <a:rPr lang="en-US"/>
               <a:t>Second level</a:t>
             </a:r>
           </a:p>
           <a:p>
             <a:pPr lvl="2"/>
             <a:r>
-              <a:rPr lang="en-US" smtClean="0"/>
+              <a:rPr lang="en-US"/>
               <a:t>Third level</a:t>
             </a:r>
           </a:p>
           <a:p>
             <a:pPr lvl="3"/>
             <a:r>
-              <a:rPr lang="en-US" smtClean="0"/>
+              <a:rPr lang="en-US"/>
               <a:t>Fourth level</a:t>
             </a:r>
           </a:p>
           <a:p>
             <a:pPr lvl="4"/>
             <a:r>
-              <a:rPr lang="en-US" smtClean="0"/>
+              <a:rPr lang="en-US"/>
               <a:t>Fifth level</a:t>
             </a:r>
-            <a:endParaRPr lang="en-US"/>
           </a:p>
         </p:txBody>
       </p:sp>
@@ -1184,38 +1180,37 @@
           <a:p>
             <a:pPr lvl="0"/>
             <a:r>
-              <a:rPr lang="en-US" smtClean="0"/>
+              <a:rPr lang="en-US"/>
               <a:t>Click to edit Master text styles</a:t>
             </a:r>
           </a:p>
           <a:p>
             <a:pPr lvl="1"/>
             <a:r>
-              <a:rPr lang="en-US" smtClean="0"/>
+              <a:rPr lang="en-US"/>
               <a:t>Second level</a:t>
             </a:r>
           </a:p>
           <a:p>
             <a:pPr lvl="2"/>
             <a:r>
-              <a:rPr lang="en-US" smtClean="0"/>
+              <a:rPr lang="en-US"/>
               <a:t>Third level</a:t>
             </a:r>
           </a:p>
           <a:p>
             <a:pPr lvl="3"/>
             <a:r>
-              <a:rPr lang="en-US" smtClean="0"/>
+              <a:rPr lang="en-US"/>
               <a:t>Fourth level</a:t>
             </a:r>
           </a:p>
           <a:p>
             <a:pPr lvl="4"/>
             <a:r>
-              <a:rPr lang="en-US" smtClean="0"/>
+              <a:rPr lang="en-US"/>
               <a:t>Fifth level</a:t>
             </a:r>
-            <a:endParaRPr lang="en-US"/>
           </a:p>
         </p:txBody>
       </p:sp>
@@ -1236,7 +1231,7 @@
           <a:p>
             <a:fld id="{5CD31FE7-93CC-4E45-AF1D-A5855231BD86}" type="datetimeFigureOut">
               <a:rPr lang="en-US" smtClean="0"/>
-              <a:t>1/13/2016</a:t>
+              <a:t>10/20/2025</a:t>
             </a:fld>
             <a:endParaRPr lang="en-US"/>
           </a:p>
@@ -1335,10 +1330,9 @@
           <a:lstStyle/>
           <a:p>
             <a:r>
-              <a:rPr lang="en-US" smtClean="0"/>
+              <a:rPr lang="en-US"/>
               <a:t>Click to edit Master title style</a:t>
             </a:r>
-            <a:endParaRPr lang="en-US"/>
           </a:p>
         </p:txBody>
       </p:sp>
@@ -1401,7 +1395,7 @@
           <a:p>
             <a:pPr lvl="0"/>
             <a:r>
-              <a:rPr lang="en-US" smtClean="0"/>
+              <a:rPr lang="en-US"/>
               <a:t>Click to edit Master text styles</a:t>
             </a:r>
           </a:p>
@@ -1429,38 +1423,37 @@
           <a:p>
             <a:pPr lvl="0"/>
             <a:r>
-              <a:rPr lang="en-US" smtClean="0"/>
+              <a:rPr lang="en-US"/>
               <a:t>Click to edit Master text styles</a:t>
             </a:r>
           </a:p>
           <a:p>
             <a:pPr lvl="1"/>
             <a:r>
-              <a:rPr lang="en-US" smtClean="0"/>
+              <a:rPr lang="en-US"/>
               <a:t>Second level</a:t>
             </a:r>
           </a:p>
           <a:p>
             <a:pPr lvl="2"/>
             <a:r>
-              <a:rPr lang="en-US" smtClean="0"/>
+              <a:rPr lang="en-US"/>
               <a:t>Third level</a:t>
             </a:r>
           </a:p>
           <a:p>
             <a:pPr lvl="3"/>
             <a:r>
-              <a:rPr lang="en-US" smtClean="0"/>
+              <a:rPr lang="en-US"/>
               <a:t>Fourth level</a:t>
             </a:r>
           </a:p>
           <a:p>
             <a:pPr lvl="4"/>
             <a:r>
-              <a:rPr lang="en-US" smtClean="0"/>
+              <a:rPr lang="en-US"/>
               <a:t>Fifth level</a:t>
             </a:r>
-            <a:endParaRPr lang="en-US"/>
           </a:p>
         </p:txBody>
       </p:sp>
@@ -1523,7 +1516,7 @@
           <a:p>
             <a:pPr lvl="0"/>
             <a:r>
-              <a:rPr lang="en-US" smtClean="0"/>
+              <a:rPr lang="en-US"/>
               <a:t>Click to edit Master text styles</a:t>
             </a:r>
           </a:p>
@@ -1551,38 +1544,37 @@
           <a:p>
             <a:pPr lvl="0"/>
             <a:r>
-              <a:rPr lang="en-US" smtClean="0"/>
+              <a:rPr lang="en-US"/>
               <a:t>Click to edit Master text styles</a:t>
             </a:r>
           </a:p>
           <a:p>
             <a:pPr lvl="1"/>
             <a:r>
-              <a:rPr lang="en-US" smtClean="0"/>
+              <a:rPr lang="en-US"/>
               <a:t>Second level</a:t>
             </a:r>
           </a:p>
           <a:p>
             <a:pPr lvl="2"/>
             <a:r>
-              <a:rPr lang="en-US" smtClean="0"/>
+              <a:rPr lang="en-US"/>
               <a:t>Third level</a:t>
             </a:r>
           </a:p>
           <a:p>
             <a:pPr lvl="3"/>
             <a:r>
-              <a:rPr lang="en-US" smtClean="0"/>
+              <a:rPr lang="en-US"/>
               <a:t>Fourth level</a:t>
             </a:r>
           </a:p>
           <a:p>
             <a:pPr lvl="4"/>
             <a:r>
-              <a:rPr lang="en-US" smtClean="0"/>
+              <a:rPr lang="en-US"/>
               <a:t>Fifth level</a:t>
             </a:r>
-            <a:endParaRPr lang="en-US"/>
           </a:p>
         </p:txBody>
       </p:sp>
@@ -1603,7 +1595,7 @@
           <a:p>
             <a:fld id="{5CD31FE7-93CC-4E45-AF1D-A5855231BD86}" type="datetimeFigureOut">
               <a:rPr lang="en-US" smtClean="0"/>
-              <a:t>1/13/2016</a:t>
+              <a:t>10/20/2025</a:t>
             </a:fld>
             <a:endParaRPr lang="en-US"/>
           </a:p>
@@ -1697,10 +1689,9 @@
           <a:lstStyle/>
           <a:p>
             <a:r>
-              <a:rPr lang="en-US" smtClean="0"/>
+              <a:rPr lang="en-US"/>
               <a:t>Click to edit Master title style</a:t>
             </a:r>
-            <a:endParaRPr lang="en-US"/>
           </a:p>
         </p:txBody>
       </p:sp>
@@ -1721,7 +1712,7 @@
           <a:p>
             <a:fld id="{5CD31FE7-93CC-4E45-AF1D-A5855231BD86}" type="datetimeFigureOut">
               <a:rPr lang="en-US" smtClean="0"/>
-              <a:t>1/13/2016</a:t>
+              <a:t>10/20/2025</a:t>
             </a:fld>
             <a:endParaRPr lang="en-US"/>
           </a:p>
@@ -1816,7 +1807,7 @@
           <a:p>
             <a:fld id="{5CD31FE7-93CC-4E45-AF1D-A5855231BD86}" type="datetimeFigureOut">
               <a:rPr lang="en-US" smtClean="0"/>
-              <a:t>1/13/2016</a:t>
+              <a:t>10/20/2025</a:t>
             </a:fld>
             <a:endParaRPr lang="en-US"/>
           </a:p>
@@ -1919,10 +1910,9 @@
           </a:lstStyle>
           <a:p>
             <a:r>
-              <a:rPr lang="en-US" smtClean="0"/>
+              <a:rPr lang="en-US"/>
               <a:t>Click to edit Master title style</a:t>
             </a:r>
-            <a:endParaRPr lang="en-US"/>
           </a:p>
         </p:txBody>
       </p:sp>
@@ -1976,38 +1966,37 @@
           <a:p>
             <a:pPr lvl="0"/>
             <a:r>
-              <a:rPr lang="en-US" smtClean="0"/>
+              <a:rPr lang="en-US"/>
               <a:t>Click to edit Master text styles</a:t>
             </a:r>
           </a:p>
           <a:p>
             <a:pPr lvl="1"/>
             <a:r>
-              <a:rPr lang="en-US" smtClean="0"/>
+              <a:rPr lang="en-US"/>
               <a:t>Second level</a:t>
             </a:r>
           </a:p>
           <a:p>
             <a:pPr lvl="2"/>
             <a:r>
-              <a:rPr lang="en-US" smtClean="0"/>
+              <a:rPr lang="en-US"/>
               <a:t>Third level</a:t>
             </a:r>
           </a:p>
           <a:p>
             <a:pPr lvl="3"/>
             <a:r>
-              <a:rPr lang="en-US" smtClean="0"/>
+              <a:rPr lang="en-US"/>
               <a:t>Fourth level</a:t>
             </a:r>
           </a:p>
           <a:p>
             <a:pPr lvl="4"/>
             <a:r>
-              <a:rPr lang="en-US" smtClean="0"/>
+              <a:rPr lang="en-US"/>
               <a:t>Fifth level</a:t>
             </a:r>
-            <a:endParaRPr lang="en-US"/>
           </a:p>
         </p:txBody>
       </p:sp>
@@ -2070,7 +2059,7 @@
           <a:p>
             <a:pPr lvl="0"/>
             <a:r>
-              <a:rPr lang="en-US" smtClean="0"/>
+              <a:rPr lang="en-US"/>
               <a:t>Click to edit Master text styles</a:t>
             </a:r>
           </a:p>
@@ -2093,7 +2082,7 @@
           <a:p>
             <a:fld id="{5CD31FE7-93CC-4E45-AF1D-A5855231BD86}" type="datetimeFigureOut">
               <a:rPr lang="en-US" smtClean="0"/>
-              <a:t>1/13/2016</a:t>
+              <a:t>10/20/2025</a:t>
             </a:fld>
             <a:endParaRPr lang="en-US"/>
           </a:p>
@@ -2196,10 +2185,9 @@
           </a:lstStyle>
           <a:p>
             <a:r>
-              <a:rPr lang="en-US" smtClean="0"/>
+              <a:rPr lang="en-US"/>
               <a:t>Click to edit Master title style</a:t>
             </a:r>
-            <a:endParaRPr lang="en-US"/>
           </a:p>
         </p:txBody>
       </p:sp>
@@ -2323,7 +2311,7 @@
           <a:p>
             <a:pPr lvl="0"/>
             <a:r>
-              <a:rPr lang="en-US" smtClean="0"/>
+              <a:rPr lang="en-US"/>
               <a:t>Click to edit Master text styles</a:t>
             </a:r>
           </a:p>
@@ -2346,7 +2334,7 @@
           <a:p>
             <a:fld id="{5CD31FE7-93CC-4E45-AF1D-A5855231BD86}" type="datetimeFigureOut">
               <a:rPr lang="en-US" smtClean="0"/>
-              <a:t>1/13/2016</a:t>
+              <a:t>10/20/2025</a:t>
             </a:fld>
             <a:endParaRPr lang="en-US"/>
           </a:p>
@@ -2455,10 +2443,9 @@
           <a:lstStyle/>
           <a:p>
             <a:r>
-              <a:rPr lang="en-US" smtClean="0"/>
+              <a:rPr lang="en-US"/>
               <a:t>Click to edit Master title style</a:t>
             </a:r>
-            <a:endParaRPr lang="en-US"/>
           </a:p>
         </p:txBody>
       </p:sp>
@@ -2489,38 +2476,37 @@
           <a:p>
             <a:pPr lvl="0"/>
             <a:r>
-              <a:rPr lang="en-US" smtClean="0"/>
+              <a:rPr lang="en-US"/>
               <a:t>Click to edit Master text styles</a:t>
             </a:r>
           </a:p>
           <a:p>
             <a:pPr lvl="1"/>
             <a:r>
-              <a:rPr lang="en-US" smtClean="0"/>
+              <a:rPr lang="en-US"/>
               <a:t>Second level</a:t>
             </a:r>
           </a:p>
           <a:p>
             <a:pPr lvl="2"/>
             <a:r>
-              <a:rPr lang="en-US" smtClean="0"/>
+              <a:rPr lang="en-US"/>
               <a:t>Third level</a:t>
             </a:r>
           </a:p>
           <a:p>
             <a:pPr lvl="3"/>
             <a:r>
-              <a:rPr lang="en-US" smtClean="0"/>
+              <a:rPr lang="en-US"/>
               <a:t>Fourth level</a:t>
             </a:r>
           </a:p>
           <a:p>
             <a:pPr lvl="4"/>
             <a:r>
-              <a:rPr lang="en-US" smtClean="0"/>
+              <a:rPr lang="en-US"/>
               <a:t>Fifth level</a:t>
             </a:r>
-            <a:endParaRPr lang="en-US"/>
           </a:p>
         </p:txBody>
       </p:sp>
@@ -2559,7 +2545,7 @@
           <a:p>
             <a:fld id="{5CD31FE7-93CC-4E45-AF1D-A5855231BD86}" type="datetimeFigureOut">
               <a:rPr lang="en-US" smtClean="0"/>
-              <a:t>1/13/2016</a:t>
+              <a:t>10/20/2025</a:t>
             </a:fld>
             <a:endParaRPr lang="en-US"/>
           </a:p>
@@ -3210,10 +3196,1156 @@
           </a:p>
         </p:txBody>
       </p:sp>
+      <p:sp>
+        <p:nvSpPr>
+          <p:cNvPr id="2" name="TextBox 1">
+            <a:extLst>
+              <a:ext uri="{FF2B5EF4-FFF2-40B4-BE49-F238E27FC236}">
+                <a16:creationId xmlns:a16="http://schemas.microsoft.com/office/drawing/2014/main" id="{4EE820DC-96A9-B534-8522-75210D478B3E}"/>
+              </a:ext>
+            </a:extLst>
+          </p:cNvPr>
+          <p:cNvSpPr txBox="1"/>
+          <p:nvPr/>
+        </p:nvSpPr>
+        <p:spPr>
+          <a:xfrm>
+            <a:off x="1211580" y="545815"/>
+            <a:ext cx="3634740" cy="369332"/>
+          </a:xfrm>
+          <a:prstGeom prst="rect">
+            <a:avLst/>
+          </a:prstGeom>
+          <a:noFill/>
+        </p:spPr>
+        <p:txBody>
+          <a:bodyPr wrap="square" rtlCol="0">
+            <a:spAutoFit/>
+          </a:bodyPr>
+          <a:lstStyle/>
+          <a:p>
+            <a:r>
+              <a:rPr lang="en-US" dirty="0"/>
+              <a:t>Original</a:t>
+            </a:r>
+          </a:p>
+        </p:txBody>
+      </p:sp>
     </p:spTree>
     <p:extLst>
       <p:ext uri="{BB962C8B-B14F-4D97-AF65-F5344CB8AC3E}">
         <p14:creationId xmlns:p14="http://schemas.microsoft.com/office/powerpoint/2010/main" val="3223732427"/>
+      </p:ext>
+    </p:extLst>
+  </p:cSld>
+  <p:clrMapOvr>
+    <a:masterClrMapping/>
+  </p:clrMapOvr>
+</p:sld>
+</file>
+
+<file path=ppt/slides/slide2.xml><?xml version="1.0" encoding="utf-8"?>
+<p:sld xmlns:a="http://schemas.openxmlformats.org/drawingml/2006/main" xmlns:r="http://schemas.openxmlformats.org/officeDocument/2006/relationships" xmlns:p="http://schemas.openxmlformats.org/presentationml/2006/main">
+  <p:cSld>
+    <p:spTree>
+      <p:nvGrpSpPr>
+        <p:cNvPr id="1" name="">
+          <a:extLst>
+            <a:ext uri="{FF2B5EF4-FFF2-40B4-BE49-F238E27FC236}">
+              <a16:creationId xmlns:a16="http://schemas.microsoft.com/office/drawing/2014/main" id="{E6958114-6E4B-ADDD-A014-F7F7DA8A7D0E}"/>
+            </a:ext>
+          </a:extLst>
+        </p:cNvPr>
+        <p:cNvGrpSpPr/>
+        <p:nvPr/>
+      </p:nvGrpSpPr>
+      <p:grpSpPr>
+        <a:xfrm>
+          <a:off x="0" y="0"/>
+          <a:ext cx="0" cy="0"/>
+          <a:chOff x="0" y="0"/>
+          <a:chExt cx="0" cy="0"/>
+        </a:xfrm>
+      </p:grpSpPr>
+      <p:sp>
+        <p:nvSpPr>
+          <p:cNvPr id="4" name="Rectangle 3">
+            <a:extLst>
+              <a:ext uri="{FF2B5EF4-FFF2-40B4-BE49-F238E27FC236}">
+                <a16:creationId xmlns:a16="http://schemas.microsoft.com/office/drawing/2014/main" id="{9583ECE3-4B3C-1182-DA02-F6BEA0B7F7E1}"/>
+              </a:ext>
+            </a:extLst>
+          </p:cNvPr>
+          <p:cNvSpPr>
+            <a:spLocks noChangeAspect="1"/>
+          </p:cNvSpPr>
+          <p:nvPr/>
+        </p:nvSpPr>
+        <p:spPr>
+          <a:xfrm>
+            <a:off x="1802562" y="2649564"/>
+            <a:ext cx="2253082" cy="2254435"/>
+          </a:xfrm>
+          <a:prstGeom prst="rect">
+            <a:avLst/>
+          </a:prstGeom>
+          <a:solidFill>
+            <a:schemeClr val="accent5">
+              <a:lumMod val="75000"/>
+            </a:schemeClr>
+          </a:solidFill>
+          <a:ln>
+            <a:noFill/>
+          </a:ln>
+        </p:spPr>
+        <p:style>
+          <a:lnRef idx="2">
+            <a:schemeClr val="accent1">
+              <a:shade val="50000"/>
+            </a:schemeClr>
+          </a:lnRef>
+          <a:fillRef idx="1">
+            <a:schemeClr val="accent1"/>
+          </a:fillRef>
+          <a:effectRef idx="0">
+            <a:schemeClr val="accent1"/>
+          </a:effectRef>
+          <a:fontRef idx="minor">
+            <a:schemeClr val="lt1"/>
+          </a:fontRef>
+        </p:style>
+        <p:txBody>
+          <a:bodyPr rtlCol="0" anchor="ctr"/>
+          <a:lstStyle/>
+          <a:p>
+            <a:pPr algn="ctr"/>
+            <a:endParaRPr lang="en-US"/>
+          </a:p>
+        </p:txBody>
+      </p:sp>
+      <p:sp>
+        <p:nvSpPr>
+          <p:cNvPr id="11" name="Block Arc 10">
+            <a:extLst>
+              <a:ext uri="{FF2B5EF4-FFF2-40B4-BE49-F238E27FC236}">
+                <a16:creationId xmlns:a16="http://schemas.microsoft.com/office/drawing/2014/main" id="{57D60D29-80DE-D2C0-06E5-ACB982393C4F}"/>
+              </a:ext>
+            </a:extLst>
+          </p:cNvPr>
+          <p:cNvSpPr/>
+          <p:nvPr/>
+        </p:nvSpPr>
+        <p:spPr>
+          <a:xfrm rot="8272644">
+            <a:off x="2098132" y="2965356"/>
+            <a:ext cx="1622854" cy="1622854"/>
+          </a:xfrm>
+          <a:prstGeom prst="blockArc">
+            <a:avLst>
+              <a:gd name="adj1" fmla="val 10800000"/>
+              <a:gd name="adj2" fmla="val 83578"/>
+              <a:gd name="adj3" fmla="val 8236"/>
+            </a:avLst>
+          </a:prstGeom>
+          <a:solidFill>
+            <a:schemeClr val="bg1"/>
+          </a:solidFill>
+          <a:ln>
+            <a:noFill/>
+          </a:ln>
+        </p:spPr>
+        <p:style>
+          <a:lnRef idx="2">
+            <a:schemeClr val="accent1">
+              <a:shade val="50000"/>
+            </a:schemeClr>
+          </a:lnRef>
+          <a:fillRef idx="1">
+            <a:schemeClr val="accent1"/>
+          </a:fillRef>
+          <a:effectRef idx="0">
+            <a:schemeClr val="accent1"/>
+          </a:effectRef>
+          <a:fontRef idx="minor">
+            <a:schemeClr val="lt1"/>
+          </a:fontRef>
+        </p:style>
+        <p:txBody>
+          <a:bodyPr rtlCol="0" anchor="ctr"/>
+          <a:lstStyle/>
+          <a:p>
+            <a:pPr algn="ctr"/>
+            <a:endParaRPr lang="en-US">
+              <a:solidFill>
+                <a:schemeClr val="tx1"/>
+              </a:solidFill>
+            </a:endParaRPr>
+          </a:p>
+        </p:txBody>
+      </p:sp>
+      <p:sp>
+        <p:nvSpPr>
+          <p:cNvPr id="14" name="Oval 13">
+            <a:extLst>
+              <a:ext uri="{FF2B5EF4-FFF2-40B4-BE49-F238E27FC236}">
+                <a16:creationId xmlns:a16="http://schemas.microsoft.com/office/drawing/2014/main" id="{9E1EBBC2-34E5-1444-6B13-2FFC98D939CF}"/>
+              </a:ext>
+            </a:extLst>
+          </p:cNvPr>
+          <p:cNvSpPr/>
+          <p:nvPr/>
+        </p:nvSpPr>
+        <p:spPr>
+          <a:xfrm>
+            <a:off x="2799536" y="3666760"/>
+            <a:ext cx="220045" cy="220045"/>
+          </a:xfrm>
+          <a:prstGeom prst="ellipse">
+            <a:avLst/>
+          </a:prstGeom>
+          <a:solidFill>
+            <a:schemeClr val="bg1"/>
+          </a:solidFill>
+          <a:ln>
+            <a:noFill/>
+          </a:ln>
+        </p:spPr>
+        <p:style>
+          <a:lnRef idx="2">
+            <a:schemeClr val="accent1">
+              <a:shade val="50000"/>
+            </a:schemeClr>
+          </a:lnRef>
+          <a:fillRef idx="1">
+            <a:schemeClr val="accent1"/>
+          </a:fillRef>
+          <a:effectRef idx="0">
+            <a:schemeClr val="accent1"/>
+          </a:effectRef>
+          <a:fontRef idx="minor">
+            <a:schemeClr val="lt1"/>
+          </a:fontRef>
+        </p:style>
+        <p:txBody>
+          <a:bodyPr rtlCol="0" anchor="ctr"/>
+          <a:lstStyle/>
+          <a:p>
+            <a:pPr algn="ctr"/>
+            <a:endParaRPr lang="en-US"/>
+          </a:p>
+        </p:txBody>
+      </p:sp>
+      <p:grpSp>
+        <p:nvGrpSpPr>
+          <p:cNvPr id="3" name="Group 2">
+            <a:extLst>
+              <a:ext uri="{FF2B5EF4-FFF2-40B4-BE49-F238E27FC236}">
+                <a16:creationId xmlns:a16="http://schemas.microsoft.com/office/drawing/2014/main" id="{FD2EAA0C-4B5E-4AE9-87AF-D52F9F588E62}"/>
+              </a:ext>
+            </a:extLst>
+          </p:cNvPr>
+          <p:cNvGrpSpPr/>
+          <p:nvPr/>
+        </p:nvGrpSpPr>
+        <p:grpSpPr>
+          <a:xfrm>
+            <a:off x="2271727" y="3180610"/>
+            <a:ext cx="1472939" cy="761526"/>
+            <a:chOff x="2096630" y="1945197"/>
+            <a:chExt cx="1472939" cy="761526"/>
+          </a:xfrm>
+          <a:solidFill>
+            <a:schemeClr val="accent4"/>
+          </a:solidFill>
+        </p:grpSpPr>
+        <p:sp>
+          <p:nvSpPr>
+            <p:cNvPr id="13" name="Down Arrow 12">
+              <a:extLst>
+                <a:ext uri="{FF2B5EF4-FFF2-40B4-BE49-F238E27FC236}">
+                  <a16:creationId xmlns:a16="http://schemas.microsoft.com/office/drawing/2014/main" id="{F32DF13D-BEA6-0C3B-51CF-CA2FA3692F5F}"/>
+                </a:ext>
+              </a:extLst>
+            </p:cNvPr>
+            <p:cNvSpPr/>
+            <p:nvPr/>
+          </p:nvSpPr>
+          <p:spPr>
+            <a:xfrm rot="5147572">
+              <a:off x="2907343" y="2302363"/>
+              <a:ext cx="370703" cy="438018"/>
+            </a:xfrm>
+            <a:prstGeom prst="downArrow">
+              <a:avLst>
+                <a:gd name="adj1" fmla="val 32222"/>
+                <a:gd name="adj2" fmla="val 50000"/>
+              </a:avLst>
+            </a:prstGeom>
+            <a:grpFill/>
+            <a:ln>
+              <a:noFill/>
+            </a:ln>
+          </p:spPr>
+          <p:style>
+            <a:lnRef idx="2">
+              <a:schemeClr val="accent1">
+                <a:shade val="50000"/>
+              </a:schemeClr>
+            </a:lnRef>
+            <a:fillRef idx="1">
+              <a:schemeClr val="accent1"/>
+            </a:fillRef>
+            <a:effectRef idx="0">
+              <a:schemeClr val="accent1"/>
+            </a:effectRef>
+            <a:fontRef idx="minor">
+              <a:schemeClr val="lt1"/>
+            </a:fontRef>
+          </p:style>
+          <p:txBody>
+            <a:bodyPr rtlCol="0" anchor="ctr"/>
+            <a:lstStyle/>
+            <a:p>
+              <a:pPr algn="ctr"/>
+              <a:endParaRPr lang="en-US"/>
+            </a:p>
+          </p:txBody>
+        </p:sp>
+        <p:sp>
+          <p:nvSpPr>
+            <p:cNvPr id="2" name="Rectangle 1">
+              <a:extLst>
+                <a:ext uri="{FF2B5EF4-FFF2-40B4-BE49-F238E27FC236}">
+                  <a16:creationId xmlns:a16="http://schemas.microsoft.com/office/drawing/2014/main" id="{6F34C226-B9C7-773B-DEE6-26E2BBCE7830}"/>
+                </a:ext>
+              </a:extLst>
+            </p:cNvPr>
+            <p:cNvSpPr/>
+            <p:nvPr/>
+          </p:nvSpPr>
+          <p:spPr>
+            <a:xfrm rot="2651035">
+              <a:off x="2096630" y="1945197"/>
+              <a:ext cx="1472939" cy="124270"/>
+            </a:xfrm>
+            <a:prstGeom prst="rect">
+              <a:avLst/>
+            </a:prstGeom>
+            <a:grpFill/>
+            <a:ln>
+              <a:noFill/>
+            </a:ln>
+          </p:spPr>
+          <p:style>
+            <a:lnRef idx="2">
+              <a:schemeClr val="accent1">
+                <a:shade val="50000"/>
+              </a:schemeClr>
+            </a:lnRef>
+            <a:fillRef idx="1">
+              <a:schemeClr val="accent1"/>
+            </a:fillRef>
+            <a:effectRef idx="0">
+              <a:schemeClr val="accent1"/>
+            </a:effectRef>
+            <a:fontRef idx="minor">
+              <a:schemeClr val="lt1"/>
+            </a:fontRef>
+          </p:style>
+          <p:txBody>
+            <a:bodyPr rtlCol="0" anchor="ctr"/>
+            <a:lstStyle/>
+            <a:p>
+              <a:pPr algn="ctr"/>
+              <a:endParaRPr lang="en-US"/>
+            </a:p>
+          </p:txBody>
+        </p:sp>
+      </p:grpSp>
+      <p:grpSp>
+        <p:nvGrpSpPr>
+          <p:cNvPr id="5" name="Group 4">
+            <a:extLst>
+              <a:ext uri="{FF2B5EF4-FFF2-40B4-BE49-F238E27FC236}">
+                <a16:creationId xmlns:a16="http://schemas.microsoft.com/office/drawing/2014/main" id="{86308B53-7BBA-8C20-4475-788D47E87973}"/>
+              </a:ext>
+            </a:extLst>
+          </p:cNvPr>
+          <p:cNvGrpSpPr/>
+          <p:nvPr/>
+        </p:nvGrpSpPr>
+        <p:grpSpPr>
+          <a:xfrm rot="16200000" flipH="1">
+            <a:off x="1950081" y="3493863"/>
+            <a:ext cx="1468841" cy="760098"/>
+            <a:chOff x="2100149" y="1946625"/>
+            <a:chExt cx="1468841" cy="760098"/>
+          </a:xfrm>
+          <a:solidFill>
+            <a:schemeClr val="accent4"/>
+          </a:solidFill>
+        </p:grpSpPr>
+        <p:sp>
+          <p:nvSpPr>
+            <p:cNvPr id="6" name="Down Arrow 12">
+              <a:extLst>
+                <a:ext uri="{FF2B5EF4-FFF2-40B4-BE49-F238E27FC236}">
+                  <a16:creationId xmlns:a16="http://schemas.microsoft.com/office/drawing/2014/main" id="{BED825B6-F25D-ADFF-0B0C-58A3ECE5E78D}"/>
+                </a:ext>
+              </a:extLst>
+            </p:cNvPr>
+            <p:cNvSpPr/>
+            <p:nvPr/>
+          </p:nvSpPr>
+          <p:spPr>
+            <a:xfrm rot="5147572">
+              <a:off x="2907343" y="2302363"/>
+              <a:ext cx="370703" cy="438018"/>
+            </a:xfrm>
+            <a:prstGeom prst="downArrow">
+              <a:avLst>
+                <a:gd name="adj1" fmla="val 32222"/>
+                <a:gd name="adj2" fmla="val 50000"/>
+              </a:avLst>
+            </a:prstGeom>
+            <a:grpFill/>
+            <a:ln>
+              <a:noFill/>
+            </a:ln>
+          </p:spPr>
+          <p:style>
+            <a:lnRef idx="2">
+              <a:schemeClr val="accent1">
+                <a:shade val="50000"/>
+              </a:schemeClr>
+            </a:lnRef>
+            <a:fillRef idx="1">
+              <a:schemeClr val="accent1"/>
+            </a:fillRef>
+            <a:effectRef idx="0">
+              <a:schemeClr val="accent1"/>
+            </a:effectRef>
+            <a:fontRef idx="minor">
+              <a:schemeClr val="lt1"/>
+            </a:fontRef>
+          </p:style>
+          <p:txBody>
+            <a:bodyPr rtlCol="0" anchor="ctr"/>
+            <a:lstStyle/>
+            <a:p>
+              <a:pPr algn="ctr"/>
+              <a:endParaRPr lang="en-US"/>
+            </a:p>
+          </p:txBody>
+        </p:sp>
+        <p:sp>
+          <p:nvSpPr>
+            <p:cNvPr id="7" name="Rectangle 6">
+              <a:extLst>
+                <a:ext uri="{FF2B5EF4-FFF2-40B4-BE49-F238E27FC236}">
+                  <a16:creationId xmlns:a16="http://schemas.microsoft.com/office/drawing/2014/main" id="{3288AC96-1BA0-6FBD-C56E-960EACD240EE}"/>
+                </a:ext>
+              </a:extLst>
+            </p:cNvPr>
+            <p:cNvSpPr/>
+            <p:nvPr/>
+          </p:nvSpPr>
+          <p:spPr>
+            <a:xfrm rot="2651035">
+              <a:off x="2100149" y="1946625"/>
+              <a:ext cx="1468841" cy="124270"/>
+            </a:xfrm>
+            <a:prstGeom prst="rect">
+              <a:avLst/>
+            </a:prstGeom>
+            <a:grpFill/>
+            <a:ln>
+              <a:noFill/>
+            </a:ln>
+          </p:spPr>
+          <p:style>
+            <a:lnRef idx="2">
+              <a:schemeClr val="accent1">
+                <a:shade val="50000"/>
+              </a:schemeClr>
+            </a:lnRef>
+            <a:fillRef idx="1">
+              <a:schemeClr val="accent1"/>
+            </a:fillRef>
+            <a:effectRef idx="0">
+              <a:schemeClr val="accent1"/>
+            </a:effectRef>
+            <a:fontRef idx="minor">
+              <a:schemeClr val="lt1"/>
+            </a:fontRef>
+          </p:style>
+          <p:txBody>
+            <a:bodyPr rtlCol="0" anchor="ctr"/>
+            <a:lstStyle/>
+            <a:p>
+              <a:pPr algn="ctr"/>
+              <a:endParaRPr lang="en-US"/>
+            </a:p>
+          </p:txBody>
+        </p:sp>
+      </p:grpSp>
+      <p:sp>
+        <p:nvSpPr>
+          <p:cNvPr id="8" name="Partial Circle 7">
+            <a:extLst>
+              <a:ext uri="{FF2B5EF4-FFF2-40B4-BE49-F238E27FC236}">
+                <a16:creationId xmlns:a16="http://schemas.microsoft.com/office/drawing/2014/main" id="{29C09109-1E7C-6667-EE44-A02F4DDA8EC5}"/>
+              </a:ext>
+            </a:extLst>
+          </p:cNvPr>
+          <p:cNvSpPr/>
+          <p:nvPr/>
+        </p:nvSpPr>
+        <p:spPr>
+          <a:xfrm>
+            <a:off x="1002462" y="1849464"/>
+            <a:ext cx="1600200" cy="1600200"/>
+          </a:xfrm>
+          <a:prstGeom prst="pie">
+            <a:avLst>
+              <a:gd name="adj1" fmla="val 0"/>
+              <a:gd name="adj2" fmla="val 5419328"/>
+            </a:avLst>
+          </a:prstGeom>
+          <a:solidFill>
+            <a:schemeClr val="accent4"/>
+          </a:solidFill>
+          <a:ln>
+            <a:noFill/>
+          </a:ln>
+        </p:spPr>
+        <p:style>
+          <a:lnRef idx="2">
+            <a:schemeClr val="accent1">
+              <a:shade val="15000"/>
+            </a:schemeClr>
+          </a:lnRef>
+          <a:fillRef idx="1">
+            <a:schemeClr val="accent1"/>
+          </a:fillRef>
+          <a:effectRef idx="0">
+            <a:schemeClr val="accent1"/>
+          </a:effectRef>
+          <a:fontRef idx="minor">
+            <a:schemeClr val="lt1"/>
+          </a:fontRef>
+        </p:style>
+        <p:txBody>
+          <a:bodyPr rtlCol="0" anchor="ctr"/>
+          <a:lstStyle/>
+          <a:p>
+            <a:pPr algn="ctr"/>
+            <a:endParaRPr lang="en-US">
+              <a:solidFill>
+                <a:schemeClr val="tx1"/>
+              </a:solidFill>
+            </a:endParaRPr>
+          </a:p>
+        </p:txBody>
+      </p:sp>
+      <p:sp>
+        <p:nvSpPr>
+          <p:cNvPr id="9" name="TextBox 8">
+            <a:extLst>
+              <a:ext uri="{FF2B5EF4-FFF2-40B4-BE49-F238E27FC236}">
+                <a16:creationId xmlns:a16="http://schemas.microsoft.com/office/drawing/2014/main" id="{2188D3F2-6F95-F902-39E5-3711F6F05179}"/>
+              </a:ext>
+            </a:extLst>
+          </p:cNvPr>
+          <p:cNvSpPr txBox="1"/>
+          <p:nvPr/>
+        </p:nvSpPr>
+        <p:spPr>
+          <a:xfrm>
+            <a:off x="1105640" y="1960283"/>
+            <a:ext cx="3634740" cy="369332"/>
+          </a:xfrm>
+          <a:prstGeom prst="rect">
+            <a:avLst/>
+          </a:prstGeom>
+          <a:noFill/>
+        </p:spPr>
+        <p:txBody>
+          <a:bodyPr wrap="square" rtlCol="0">
+            <a:spAutoFit/>
+          </a:bodyPr>
+          <a:lstStyle/>
+          <a:p>
+            <a:r>
+              <a:rPr lang="en-US" dirty="0"/>
+              <a:t>Mock 1: Parabolic Trough</a:t>
+            </a:r>
+          </a:p>
+        </p:txBody>
+      </p:sp>
+    </p:spTree>
+    <p:extLst>
+      <p:ext uri="{BB962C8B-B14F-4D97-AF65-F5344CB8AC3E}">
+        <p14:creationId xmlns:p14="http://schemas.microsoft.com/office/powerpoint/2010/main" val="181606284"/>
+      </p:ext>
+    </p:extLst>
+  </p:cSld>
+  <p:clrMapOvr>
+    <a:masterClrMapping/>
+  </p:clrMapOvr>
+</p:sld>
+</file>
+
+<file path=ppt/slides/slide3.xml><?xml version="1.0" encoding="utf-8"?>
+<p:sld xmlns:a="http://schemas.openxmlformats.org/drawingml/2006/main" xmlns:r="http://schemas.openxmlformats.org/officeDocument/2006/relationships" xmlns:p="http://schemas.openxmlformats.org/presentationml/2006/main">
+  <p:cSld>
+    <p:spTree>
+      <p:nvGrpSpPr>
+        <p:cNvPr id="1" name="">
+          <a:extLst>
+            <a:ext uri="{FF2B5EF4-FFF2-40B4-BE49-F238E27FC236}">
+              <a16:creationId xmlns:a16="http://schemas.microsoft.com/office/drawing/2014/main" id="{04E4C1EE-B114-7534-2364-1E01D7C33FDC}"/>
+            </a:ext>
+          </a:extLst>
+        </p:cNvPr>
+        <p:cNvGrpSpPr/>
+        <p:nvPr/>
+      </p:nvGrpSpPr>
+      <p:grpSpPr>
+        <a:xfrm>
+          <a:off x="0" y="0"/>
+          <a:ext cx="0" cy="0"/>
+          <a:chOff x="0" y="0"/>
+          <a:chExt cx="0" cy="0"/>
+        </a:xfrm>
+      </p:grpSpPr>
+      <p:sp>
+        <p:nvSpPr>
+          <p:cNvPr id="4" name="Rectangle 3">
+            <a:extLst>
+              <a:ext uri="{FF2B5EF4-FFF2-40B4-BE49-F238E27FC236}">
+                <a16:creationId xmlns:a16="http://schemas.microsoft.com/office/drawing/2014/main" id="{4D19E992-849E-31FE-8008-1E7B3635CCC8}"/>
+              </a:ext>
+            </a:extLst>
+          </p:cNvPr>
+          <p:cNvSpPr>
+            <a:spLocks noChangeAspect="1"/>
+          </p:cNvSpPr>
+          <p:nvPr/>
+        </p:nvSpPr>
+        <p:spPr>
+          <a:xfrm>
+            <a:off x="1804195" y="2643849"/>
+            <a:ext cx="2253082" cy="2254435"/>
+          </a:xfrm>
+          <a:prstGeom prst="rect">
+            <a:avLst/>
+          </a:prstGeom>
+          <a:solidFill>
+            <a:schemeClr val="accent5">
+              <a:lumMod val="75000"/>
+            </a:schemeClr>
+          </a:solidFill>
+          <a:ln>
+            <a:noFill/>
+          </a:ln>
+        </p:spPr>
+        <p:style>
+          <a:lnRef idx="2">
+            <a:schemeClr val="accent1">
+              <a:shade val="50000"/>
+            </a:schemeClr>
+          </a:lnRef>
+          <a:fillRef idx="1">
+            <a:schemeClr val="accent1"/>
+          </a:fillRef>
+          <a:effectRef idx="0">
+            <a:schemeClr val="accent1"/>
+          </a:effectRef>
+          <a:fontRef idx="minor">
+            <a:schemeClr val="lt1"/>
+          </a:fontRef>
+        </p:style>
+        <p:txBody>
+          <a:bodyPr rtlCol="0" anchor="ctr"/>
+          <a:lstStyle/>
+          <a:p>
+            <a:pPr algn="ctr"/>
+            <a:endParaRPr lang="en-US"/>
+          </a:p>
+        </p:txBody>
+      </p:sp>
+      <p:sp>
+        <p:nvSpPr>
+          <p:cNvPr id="14" name="Oval 13">
+            <a:extLst>
+              <a:ext uri="{FF2B5EF4-FFF2-40B4-BE49-F238E27FC236}">
+                <a16:creationId xmlns:a16="http://schemas.microsoft.com/office/drawing/2014/main" id="{C3039E56-8937-D3B9-F984-69853B429529}"/>
+              </a:ext>
+            </a:extLst>
+          </p:cNvPr>
+          <p:cNvSpPr/>
+          <p:nvPr/>
+        </p:nvSpPr>
+        <p:spPr>
+          <a:xfrm>
+            <a:off x="2017522" y="3794049"/>
+            <a:ext cx="220045" cy="220045"/>
+          </a:xfrm>
+          <a:prstGeom prst="ellipse">
+            <a:avLst/>
+          </a:prstGeom>
+          <a:solidFill>
+            <a:schemeClr val="bg1"/>
+          </a:solidFill>
+          <a:ln>
+            <a:noFill/>
+          </a:ln>
+        </p:spPr>
+        <p:style>
+          <a:lnRef idx="2">
+            <a:schemeClr val="accent1">
+              <a:shade val="50000"/>
+            </a:schemeClr>
+          </a:lnRef>
+          <a:fillRef idx="1">
+            <a:schemeClr val="accent1"/>
+          </a:fillRef>
+          <a:effectRef idx="0">
+            <a:schemeClr val="accent1"/>
+          </a:effectRef>
+          <a:fontRef idx="minor">
+            <a:schemeClr val="lt1"/>
+          </a:fontRef>
+        </p:style>
+        <p:txBody>
+          <a:bodyPr rtlCol="0" anchor="ctr"/>
+          <a:lstStyle/>
+          <a:p>
+            <a:pPr algn="ctr"/>
+            <a:endParaRPr lang="en-US"/>
+          </a:p>
+        </p:txBody>
+      </p:sp>
+      <p:sp>
+        <p:nvSpPr>
+          <p:cNvPr id="13" name="Down Arrow 12">
+            <a:extLst>
+              <a:ext uri="{FF2B5EF4-FFF2-40B4-BE49-F238E27FC236}">
+                <a16:creationId xmlns:a16="http://schemas.microsoft.com/office/drawing/2014/main" id="{CEFB8E1D-2E3C-F7FB-8775-D7D998A65747}"/>
+              </a:ext>
+            </a:extLst>
+          </p:cNvPr>
+          <p:cNvSpPr/>
+          <p:nvPr/>
+        </p:nvSpPr>
+        <p:spPr>
+          <a:xfrm rot="5624428">
+            <a:off x="2842174" y="3283977"/>
+            <a:ext cx="147847" cy="1280160"/>
+          </a:xfrm>
+          <a:prstGeom prst="downArrow">
+            <a:avLst>
+              <a:gd name="adj1" fmla="val 52625"/>
+              <a:gd name="adj2" fmla="val 106547"/>
+            </a:avLst>
+          </a:prstGeom>
+          <a:solidFill>
+            <a:schemeClr val="accent4"/>
+          </a:solidFill>
+          <a:ln>
+            <a:noFill/>
+          </a:ln>
+        </p:spPr>
+        <p:style>
+          <a:lnRef idx="2">
+            <a:schemeClr val="accent1">
+              <a:shade val="50000"/>
+            </a:schemeClr>
+          </a:lnRef>
+          <a:fillRef idx="1">
+            <a:schemeClr val="accent1"/>
+          </a:fillRef>
+          <a:effectRef idx="0">
+            <a:schemeClr val="accent1"/>
+          </a:effectRef>
+          <a:fontRef idx="minor">
+            <a:schemeClr val="lt1"/>
+          </a:fontRef>
+        </p:style>
+        <p:txBody>
+          <a:bodyPr rtlCol="0" anchor="ctr"/>
+          <a:lstStyle/>
+          <a:p>
+            <a:pPr algn="ctr"/>
+            <a:endParaRPr lang="en-US"/>
+          </a:p>
+        </p:txBody>
+      </p:sp>
+      <p:sp>
+        <p:nvSpPr>
+          <p:cNvPr id="2" name="Rectangle 1">
+            <a:extLst>
+              <a:ext uri="{FF2B5EF4-FFF2-40B4-BE49-F238E27FC236}">
+                <a16:creationId xmlns:a16="http://schemas.microsoft.com/office/drawing/2014/main" id="{59368020-32A3-A7CA-9E06-19D9C4EA6944}"/>
+              </a:ext>
+            </a:extLst>
+          </p:cNvPr>
+          <p:cNvSpPr/>
+          <p:nvPr/>
+        </p:nvSpPr>
+        <p:spPr>
+          <a:xfrm rot="18088811">
+            <a:off x="3040960" y="4225267"/>
+            <a:ext cx="980765" cy="124270"/>
+          </a:xfrm>
+          <a:prstGeom prst="rect">
+            <a:avLst/>
+          </a:prstGeom>
+          <a:solidFill>
+            <a:schemeClr val="bg1"/>
+          </a:solidFill>
+          <a:ln>
+            <a:noFill/>
+          </a:ln>
+        </p:spPr>
+        <p:style>
+          <a:lnRef idx="2">
+            <a:schemeClr val="accent1">
+              <a:shade val="50000"/>
+            </a:schemeClr>
+          </a:lnRef>
+          <a:fillRef idx="1">
+            <a:schemeClr val="accent1"/>
+          </a:fillRef>
+          <a:effectRef idx="0">
+            <a:schemeClr val="accent1"/>
+          </a:effectRef>
+          <a:fontRef idx="minor">
+            <a:schemeClr val="lt1"/>
+          </a:fontRef>
+        </p:style>
+        <p:txBody>
+          <a:bodyPr rtlCol="0" anchor="ctr"/>
+          <a:lstStyle/>
+          <a:p>
+            <a:pPr algn="ctr"/>
+            <a:endParaRPr lang="en-US"/>
+          </a:p>
+        </p:txBody>
+      </p:sp>
+      <p:sp>
+        <p:nvSpPr>
+          <p:cNvPr id="7" name="Rectangle 6">
+            <a:extLst>
+              <a:ext uri="{FF2B5EF4-FFF2-40B4-BE49-F238E27FC236}">
+                <a16:creationId xmlns:a16="http://schemas.microsoft.com/office/drawing/2014/main" id="{02D4C188-730D-8A75-30B7-8AD88D2478E8}"/>
+              </a:ext>
+            </a:extLst>
+          </p:cNvPr>
+          <p:cNvSpPr/>
+          <p:nvPr/>
+        </p:nvSpPr>
+        <p:spPr>
+          <a:xfrm rot="13412630" flipH="1">
+            <a:off x="2317349" y="3422715"/>
+            <a:ext cx="1463040" cy="91440"/>
+          </a:xfrm>
+          <a:prstGeom prst="rect">
+            <a:avLst/>
+          </a:prstGeom>
+          <a:solidFill>
+            <a:schemeClr val="accent4"/>
+          </a:solidFill>
+          <a:ln>
+            <a:noFill/>
+          </a:ln>
+        </p:spPr>
+        <p:style>
+          <a:lnRef idx="2">
+            <a:schemeClr val="accent1">
+              <a:shade val="50000"/>
+            </a:schemeClr>
+          </a:lnRef>
+          <a:fillRef idx="1">
+            <a:schemeClr val="accent1"/>
+          </a:fillRef>
+          <a:effectRef idx="0">
+            <a:schemeClr val="accent1"/>
+          </a:effectRef>
+          <a:fontRef idx="minor">
+            <a:schemeClr val="lt1"/>
+          </a:fontRef>
+        </p:style>
+        <p:txBody>
+          <a:bodyPr rtlCol="0" anchor="ctr"/>
+          <a:lstStyle/>
+          <a:p>
+            <a:pPr algn="ctr"/>
+            <a:endParaRPr lang="en-US" dirty="0"/>
+          </a:p>
+        </p:txBody>
+      </p:sp>
+      <p:sp>
+        <p:nvSpPr>
+          <p:cNvPr id="8" name="Partial Circle 7">
+            <a:extLst>
+              <a:ext uri="{FF2B5EF4-FFF2-40B4-BE49-F238E27FC236}">
+                <a16:creationId xmlns:a16="http://schemas.microsoft.com/office/drawing/2014/main" id="{0ED39133-5BC2-17CD-F7DA-47692471B899}"/>
+              </a:ext>
+            </a:extLst>
+          </p:cNvPr>
+          <p:cNvSpPr/>
+          <p:nvPr/>
+        </p:nvSpPr>
+        <p:spPr>
+          <a:xfrm>
+            <a:off x="1002462" y="1849464"/>
+            <a:ext cx="1600200" cy="1600200"/>
+          </a:xfrm>
+          <a:prstGeom prst="pie">
+            <a:avLst>
+              <a:gd name="adj1" fmla="val 0"/>
+              <a:gd name="adj2" fmla="val 5419328"/>
+            </a:avLst>
+          </a:prstGeom>
+          <a:solidFill>
+            <a:schemeClr val="accent4"/>
+          </a:solidFill>
+          <a:ln>
+            <a:noFill/>
+          </a:ln>
+        </p:spPr>
+        <p:style>
+          <a:lnRef idx="2">
+            <a:schemeClr val="accent1">
+              <a:shade val="15000"/>
+            </a:schemeClr>
+          </a:lnRef>
+          <a:fillRef idx="1">
+            <a:schemeClr val="accent1"/>
+          </a:fillRef>
+          <a:effectRef idx="0">
+            <a:schemeClr val="accent1"/>
+          </a:effectRef>
+          <a:fontRef idx="minor">
+            <a:schemeClr val="lt1"/>
+          </a:fontRef>
+        </p:style>
+        <p:txBody>
+          <a:bodyPr rtlCol="0" anchor="ctr"/>
+          <a:lstStyle/>
+          <a:p>
+            <a:pPr algn="ctr"/>
+            <a:endParaRPr lang="en-US">
+              <a:solidFill>
+                <a:schemeClr val="tx1"/>
+              </a:solidFill>
+            </a:endParaRPr>
+          </a:p>
+        </p:txBody>
+      </p:sp>
+      <p:sp>
+        <p:nvSpPr>
+          <p:cNvPr id="9" name="TextBox 8">
+            <a:extLst>
+              <a:ext uri="{FF2B5EF4-FFF2-40B4-BE49-F238E27FC236}">
+                <a16:creationId xmlns:a16="http://schemas.microsoft.com/office/drawing/2014/main" id="{32D91759-B353-4E06-00C4-A8018ED4C118}"/>
+              </a:ext>
+            </a:extLst>
+          </p:cNvPr>
+          <p:cNvSpPr txBox="1"/>
+          <p:nvPr/>
+        </p:nvSpPr>
+        <p:spPr>
+          <a:xfrm>
+            <a:off x="1308498" y="1820109"/>
+            <a:ext cx="3634740" cy="369332"/>
+          </a:xfrm>
+          <a:prstGeom prst="rect">
+            <a:avLst/>
+          </a:prstGeom>
+          <a:noFill/>
+        </p:spPr>
+        <p:txBody>
+          <a:bodyPr wrap="square" rtlCol="0">
+            <a:spAutoFit/>
+          </a:bodyPr>
+          <a:lstStyle/>
+          <a:p>
+            <a:r>
+              <a:rPr lang="en-US" dirty="0"/>
+              <a:t>Mock 2: Heliostat</a:t>
+            </a:r>
+          </a:p>
+        </p:txBody>
+      </p:sp>
+      <p:sp>
+        <p:nvSpPr>
+          <p:cNvPr id="12" name="Rectangle 11">
+            <a:extLst>
+              <a:ext uri="{FF2B5EF4-FFF2-40B4-BE49-F238E27FC236}">
+                <a16:creationId xmlns:a16="http://schemas.microsoft.com/office/drawing/2014/main" id="{3F693AAA-0FCF-5894-A0DE-CAF6C244CC30}"/>
+              </a:ext>
+            </a:extLst>
+          </p:cNvPr>
+          <p:cNvSpPr/>
+          <p:nvPr/>
+        </p:nvSpPr>
+        <p:spPr>
+          <a:xfrm rot="13412630" flipH="1">
+            <a:off x="1853551" y="3879815"/>
+            <a:ext cx="1645920" cy="91440"/>
+          </a:xfrm>
+          <a:prstGeom prst="rect">
+            <a:avLst/>
+          </a:prstGeom>
+          <a:solidFill>
+            <a:schemeClr val="accent4"/>
+          </a:solidFill>
+          <a:ln>
+            <a:noFill/>
+          </a:ln>
+        </p:spPr>
+        <p:style>
+          <a:lnRef idx="2">
+            <a:schemeClr val="accent1">
+              <a:shade val="50000"/>
+            </a:schemeClr>
+          </a:lnRef>
+          <a:fillRef idx="1">
+            <a:schemeClr val="accent1"/>
+          </a:fillRef>
+          <a:effectRef idx="0">
+            <a:schemeClr val="accent1"/>
+          </a:effectRef>
+          <a:fontRef idx="minor">
+            <a:schemeClr val="lt1"/>
+          </a:fontRef>
+        </p:style>
+        <p:txBody>
+          <a:bodyPr rtlCol="0" anchor="ctr"/>
+          <a:lstStyle/>
+          <a:p>
+            <a:pPr algn="ctr"/>
+            <a:endParaRPr lang="en-US" dirty="0"/>
+          </a:p>
+        </p:txBody>
+      </p:sp>
+      <p:sp>
+        <p:nvSpPr>
+          <p:cNvPr id="15" name="Down Arrow 12">
+            <a:extLst>
+              <a:ext uri="{FF2B5EF4-FFF2-40B4-BE49-F238E27FC236}">
+                <a16:creationId xmlns:a16="http://schemas.microsoft.com/office/drawing/2014/main" id="{624ABBA7-C831-918E-45D8-A09F1C789905}"/>
+              </a:ext>
+            </a:extLst>
+          </p:cNvPr>
+          <p:cNvSpPr/>
+          <p:nvPr/>
+        </p:nvSpPr>
+        <p:spPr>
+          <a:xfrm rot="6950936">
+            <a:off x="2680657" y="3684038"/>
+            <a:ext cx="146304" cy="1122153"/>
+          </a:xfrm>
+          <a:prstGeom prst="downArrow">
+            <a:avLst>
+              <a:gd name="adj1" fmla="val 52625"/>
+              <a:gd name="adj2" fmla="val 106547"/>
+            </a:avLst>
+          </a:prstGeom>
+          <a:solidFill>
+            <a:schemeClr val="accent4"/>
+          </a:solidFill>
+          <a:ln>
+            <a:noFill/>
+          </a:ln>
+        </p:spPr>
+        <p:style>
+          <a:lnRef idx="2">
+            <a:schemeClr val="accent1">
+              <a:shade val="50000"/>
+            </a:schemeClr>
+          </a:lnRef>
+          <a:fillRef idx="1">
+            <a:schemeClr val="accent1"/>
+          </a:fillRef>
+          <a:effectRef idx="0">
+            <a:schemeClr val="accent1"/>
+          </a:effectRef>
+          <a:fontRef idx="minor">
+            <a:schemeClr val="lt1"/>
+          </a:fontRef>
+        </p:style>
+        <p:txBody>
+          <a:bodyPr rtlCol="0" anchor="ctr"/>
+          <a:lstStyle/>
+          <a:p>
+            <a:pPr algn="ctr"/>
+            <a:endParaRPr lang="en-US"/>
+          </a:p>
+        </p:txBody>
+      </p:sp>
+      <p:sp>
+        <p:nvSpPr>
+          <p:cNvPr id="16" name="Down Arrow 12">
+            <a:extLst>
+              <a:ext uri="{FF2B5EF4-FFF2-40B4-BE49-F238E27FC236}">
+                <a16:creationId xmlns:a16="http://schemas.microsoft.com/office/drawing/2014/main" id="{DB40320D-CD71-7EC8-836F-E8ED536CC26B}"/>
+              </a:ext>
+            </a:extLst>
+          </p:cNvPr>
+          <p:cNvSpPr/>
+          <p:nvPr/>
+        </p:nvSpPr>
+        <p:spPr>
+          <a:xfrm rot="18697211">
+            <a:off x="2783567" y="2930185"/>
+            <a:ext cx="147847" cy="1554480"/>
+          </a:xfrm>
+          <a:prstGeom prst="downArrow">
+            <a:avLst>
+              <a:gd name="adj1" fmla="val 52625"/>
+              <a:gd name="adj2" fmla="val 106547"/>
+            </a:avLst>
+          </a:prstGeom>
+          <a:solidFill>
+            <a:schemeClr val="accent4"/>
+          </a:solidFill>
+          <a:ln>
+            <a:noFill/>
+          </a:ln>
+        </p:spPr>
+        <p:style>
+          <a:lnRef idx="2">
+            <a:schemeClr val="accent1">
+              <a:shade val="50000"/>
+            </a:schemeClr>
+          </a:lnRef>
+          <a:fillRef idx="1">
+            <a:schemeClr val="accent1"/>
+          </a:fillRef>
+          <a:effectRef idx="0">
+            <a:schemeClr val="accent1"/>
+          </a:effectRef>
+          <a:fontRef idx="minor">
+            <a:schemeClr val="lt1"/>
+          </a:fontRef>
+        </p:style>
+        <p:txBody>
+          <a:bodyPr rtlCol="0" anchor="ctr"/>
+          <a:lstStyle/>
+          <a:p>
+            <a:pPr algn="ctr"/>
+            <a:endParaRPr lang="en-US"/>
+          </a:p>
+        </p:txBody>
+      </p:sp>
+    </p:spTree>
+    <p:extLst>
+      <p:ext uri="{BB962C8B-B14F-4D97-AF65-F5344CB8AC3E}">
+        <p14:creationId xmlns:p14="http://schemas.microsoft.com/office/powerpoint/2010/main" val="1765859184"/>
       </p:ext>
     </p:extLst>
   </p:cSld>
@@ -3482,4 +4614,10 @@
     </a:ext>
   </a:extLst>
 </a:theme>
+</file>
+
+<file path=docMetadata/LabelInfo.xml><?xml version="1.0" encoding="utf-8"?>
+<clbl:labelList xmlns:clbl="http://schemas.microsoft.com/office/2020/mipLabelMetadata">
+  <clbl:label id="{95965d95-ecc0-4720-b759-1f33c42ed7da}" enabled="1" method="Standard" siteId="{a0f29d7e-28cd-4f54-8442-7885aee7c080}" contentBits="0" removed="0"/>
+</clbl:labelList>
 </file>
</xml_diff>